<commit_message>
Add topic illustrations to the screen-share PowerPoint decks.
Place a matching picture on title, concept, and pause slides (JSON-to-API, map/filter, formats, joins, recursion, mapping, pause). Leave code slides text-only so the script stays readable on a share.

Co-authored-by: Vivek Vishal <vivekvishal70777@users.noreply.github.com>
</commit_message>
<xml_diff>
--- a/instructor/slides/pptx/labs/01-map-salesforce-contact-to-a-shorter-api-shape.pptx
+++ b/instructor/slides/pptx/labs/01-map-salesforce-contact-to-a-shorter-api-shape.pptx
@@ -4021,8 +4021,8 @@
         </p:nvSpPr>
         <p:spPr>
           <a:xfrm>
-            <a:off x="640080" y="1920240"/>
-            <a:ext cx="10972800" cy="1463040"/>
+            <a:off x="640080" y="1828800"/>
+            <a:ext cx="6675120" cy="1645920"/>
           </a:xfrm>
           <a:prstGeom prst="rect">
             <a:avLst/>
@@ -4036,7 +4036,7 @@
           <a:lstStyle/>
           <a:p>
             <a:r>
-              <a:rPr sz="4400" b="1">
+              <a:rPr sz="4000" b="1">
                 <a:solidFill>
                   <a:srgbClr val="FFFFFF"/>
                 </a:solidFill>
@@ -4055,8 +4055,8 @@
         </p:nvSpPr>
         <p:spPr>
           <a:xfrm>
-            <a:off x="640080" y="3657600"/>
-            <a:ext cx="10789920" cy="1097280"/>
+            <a:off x="640080" y="3794760"/>
+            <a:ext cx="6675120" cy="1097280"/>
           </a:xfrm>
           <a:prstGeom prst="rect">
             <a:avLst/>
@@ -4070,7 +4070,7 @@
           <a:lstStyle/>
           <a:p>
             <a:r>
-              <a:rPr sz="2000" b="0">
+              <a:rPr sz="1800" b="0">
                 <a:solidFill>
                   <a:srgbClr val="B7CBDE"/>
                 </a:solidFill>
@@ -4089,8 +4089,8 @@
         </p:nvSpPr>
         <p:spPr>
           <a:xfrm>
-            <a:off x="640080" y="5029200"/>
-            <a:ext cx="10972800" cy="457200"/>
+            <a:off x="640080" y="5120640"/>
+            <a:ext cx="6766560" cy="457200"/>
           </a:xfrm>
           <a:prstGeom prst="rect">
             <a:avLst/>
@@ -4104,7 +4104,7 @@
           <a:lstStyle/>
           <a:p>
             <a:r>
-              <a:rPr sz="1600" b="0">
+              <a:rPr sz="1500" b="0">
                 <a:solidFill>
                   <a:srgbClr val="3EC6FF"/>
                 </a:solidFill>
@@ -4115,6 +4115,30 @@
           </a:p>
         </p:txBody>
       </p:sp>
+      <p:pic>
+        <p:nvPicPr>
+          <p:cNvPr id="7" name="Picture 6" descr="dw-lab.jpg"/>
+          <p:cNvPicPr>
+            <a:picLocks noChangeAspect="1"/>
+          </p:cNvPicPr>
+          <p:nvPr/>
+        </p:nvPicPr>
+        <p:blipFill>
+          <a:blip r:embed="rId2"/>
+          <a:stretch>
+            <a:fillRect/>
+          </a:stretch>
+        </p:blipFill>
+        <p:spPr>
+          <a:xfrm>
+            <a:off x="7452360" y="1325880"/>
+            <a:ext cx="4160520" cy="4160520"/>
+          </a:xfrm>
+          <a:prstGeom prst="rect">
+            <a:avLst/>
+          </a:prstGeom>
+        </p:spPr>
+      </p:pic>
     </p:spTree>
   </p:cSld>
   <p:clrMapOvr>
@@ -4218,8 +4242,8 @@
         </p:nvSpPr>
         <p:spPr>
           <a:xfrm>
-            <a:off x="640080" y="685800"/>
-            <a:ext cx="10972800" cy="1463040"/>
+            <a:off x="640080" y="658368"/>
+            <a:ext cx="7863840" cy="1645920"/>
           </a:xfrm>
           <a:prstGeom prst="rect">
             <a:avLst/>
@@ -4233,7 +4257,7 @@
           <a:lstStyle/>
           <a:p>
             <a:r>
-              <a:rPr sz="3200" b="1">
+              <a:rPr sz="3000" b="1">
                 <a:solidFill>
                   <a:srgbClr val="FFFFFF"/>
                 </a:solidFill>
@@ -4252,8 +4276,8 @@
         </p:nvSpPr>
         <p:spPr>
           <a:xfrm>
-            <a:off x="777240" y="2286000"/>
-            <a:ext cx="10607040" cy="4754880"/>
+            <a:off x="777240" y="2331720"/>
+            <a:ext cx="7498079" cy="4754880"/>
           </a:xfrm>
           <a:prstGeom prst="rect">
             <a:avLst/>
@@ -4272,7 +4296,7 @@
               </a:spcAft>
             </a:pPr>
             <a:r>
-              <a:rPr sz="2400" b="0">
+              <a:rPr sz="2200" b="0">
                 <a:solidFill>
                   <a:srgbClr val="FFFFFF"/>
                 </a:solidFill>
@@ -4288,7 +4312,7 @@
               </a:spcAft>
             </a:pPr>
             <a:r>
-              <a:rPr sz="2400" b="0">
+              <a:rPr sz="2200" b="0">
                 <a:solidFill>
                   <a:srgbClr val="FFFFFF"/>
                 </a:solidFill>
@@ -4304,7 +4328,7 @@
               </a:spcAft>
             </a:pPr>
             <a:r>
-              <a:rPr sz="2400" b="0">
+              <a:rPr sz="2200" b="0">
                 <a:solidFill>
                   <a:srgbClr val="FFFFFF"/>
                 </a:solidFill>
@@ -4315,6 +4339,30 @@
           </a:p>
         </p:txBody>
       </p:sp>
+      <p:pic>
+        <p:nvPicPr>
+          <p:cNvPr id="6" name="Picture 5" descr="dw-lab.jpg"/>
+          <p:cNvPicPr>
+            <a:picLocks noChangeAspect="1"/>
+          </p:cNvPicPr>
+          <p:nvPr/>
+        </p:nvPicPr>
+        <p:blipFill>
+          <a:blip r:embed="rId2"/>
+          <a:stretch>
+            <a:fillRect/>
+          </a:stretch>
+        </p:blipFill>
+        <p:spPr>
+          <a:xfrm>
+            <a:off x="8732520" y="2057400"/>
+            <a:ext cx="2880360" cy="2880360"/>
+          </a:xfrm>
+          <a:prstGeom prst="rect">
+            <a:avLst/>
+          </a:prstGeom>
+        </p:spPr>
+      </p:pic>
     </p:spTree>
   </p:cSld>
   <p:clrMapOvr>
@@ -4418,8 +4466,8 @@
         </p:nvSpPr>
         <p:spPr>
           <a:xfrm>
-            <a:off x="640080" y="685800"/>
-            <a:ext cx="10972800" cy="1463040"/>
+            <a:off x="640080" y="658368"/>
+            <a:ext cx="7863840" cy="1645920"/>
           </a:xfrm>
           <a:prstGeom prst="rect">
             <a:avLst/>
@@ -4433,7 +4481,7 @@
           <a:lstStyle/>
           <a:p>
             <a:r>
-              <a:rPr sz="3200" b="1">
+              <a:rPr sz="3000" b="1">
                 <a:solidFill>
                   <a:srgbClr val="FFFFFF"/>
                 </a:solidFill>
@@ -4452,8 +4500,8 @@
         </p:nvSpPr>
         <p:spPr>
           <a:xfrm>
-            <a:off x="777240" y="2286000"/>
-            <a:ext cx="10607040" cy="4754880"/>
+            <a:off x="777240" y="2331720"/>
+            <a:ext cx="7498079" cy="4754880"/>
           </a:xfrm>
           <a:prstGeom prst="rect">
             <a:avLst/>
@@ -4472,7 +4520,7 @@
               </a:spcAft>
             </a:pPr>
             <a:r>
-              <a:rPr sz="2400" b="0">
+              <a:rPr sz="2200" b="0">
                 <a:solidFill>
                   <a:srgbClr val="FFFFFF"/>
                 </a:solidFill>
@@ -4483,6 +4531,30 @@
           </a:p>
         </p:txBody>
       </p:sp>
+      <p:pic>
+        <p:nvPicPr>
+          <p:cNvPr id="6" name="Picture 5" descr="dw-lab.jpg"/>
+          <p:cNvPicPr>
+            <a:picLocks noChangeAspect="1"/>
+          </p:cNvPicPr>
+          <p:nvPr/>
+        </p:nvPicPr>
+        <p:blipFill>
+          <a:blip r:embed="rId2"/>
+          <a:stretch>
+            <a:fillRect/>
+          </a:stretch>
+        </p:blipFill>
+        <p:spPr>
+          <a:xfrm>
+            <a:off x="8732520" y="2057400"/>
+            <a:ext cx="2880360" cy="2880360"/>
+          </a:xfrm>
+          <a:prstGeom prst="rect">
+            <a:avLst/>
+          </a:prstGeom>
+        </p:spPr>
+      </p:pic>
     </p:spTree>
   </p:cSld>
   <p:clrMapOvr>
@@ -4586,8 +4658,8 @@
         </p:nvSpPr>
         <p:spPr>
           <a:xfrm>
-            <a:off x="640080" y="685800"/>
-            <a:ext cx="10972800" cy="1463040"/>
+            <a:off x="640080" y="658368"/>
+            <a:ext cx="10972800" cy="1645920"/>
           </a:xfrm>
           <a:prstGeom prst="rect">
             <a:avLst/>
@@ -4601,7 +4673,7 @@
           <a:lstStyle/>
           <a:p>
             <a:r>
-              <a:rPr sz="3200" b="1">
+              <a:rPr sz="3000" b="1">
                 <a:solidFill>
                   <a:srgbClr val="FFFFFF"/>
                 </a:solidFill>
@@ -4819,8 +4891,8 @@
         </p:nvSpPr>
         <p:spPr>
           <a:xfrm>
-            <a:off x="640080" y="685800"/>
-            <a:ext cx="10972800" cy="1463040"/>
+            <a:off x="640080" y="658368"/>
+            <a:ext cx="7863840" cy="1645920"/>
           </a:xfrm>
           <a:prstGeom prst="rect">
             <a:avLst/>
@@ -4834,7 +4906,7 @@
           <a:lstStyle/>
           <a:p>
             <a:r>
-              <a:rPr sz="3200" b="1">
+              <a:rPr sz="3000" b="1">
                 <a:solidFill>
                   <a:srgbClr val="FFFFFF"/>
                 </a:solidFill>
@@ -4853,8 +4925,8 @@
         </p:nvSpPr>
         <p:spPr>
           <a:xfrm>
-            <a:off x="777240" y="2286000"/>
-            <a:ext cx="10607040" cy="4754880"/>
+            <a:off x="777240" y="2331720"/>
+            <a:ext cx="7498079" cy="4754880"/>
           </a:xfrm>
           <a:prstGeom prst="rect">
             <a:avLst/>
@@ -4873,7 +4945,7 @@
               </a:spcAft>
             </a:pPr>
             <a:r>
-              <a:rPr sz="2400" b="0">
+              <a:rPr sz="2200" b="0">
                 <a:solidFill>
                   <a:srgbClr val="FFB020"/>
                 </a:solidFill>
@@ -4889,7 +4961,7 @@
               </a:spcAft>
             </a:pPr>
             <a:r>
-              <a:rPr sz="2400" b="0">
+              <a:rPr sz="2200" b="0">
                 <a:solidFill>
                   <a:srgbClr val="FFB020"/>
                 </a:solidFill>
@@ -4905,7 +4977,7 @@
               </a:spcAft>
             </a:pPr>
             <a:r>
-              <a:rPr sz="2400" b="0">
+              <a:rPr sz="2200" b="0">
                 <a:solidFill>
                   <a:srgbClr val="FFB020"/>
                 </a:solidFill>
@@ -4921,7 +4993,7 @@
               </a:spcAft>
             </a:pPr>
             <a:r>
-              <a:rPr sz="2400" b="0">
+              <a:rPr sz="2200" b="0">
                 <a:solidFill>
                   <a:srgbClr val="FFB020"/>
                 </a:solidFill>
@@ -4932,6 +5004,30 @@
           </a:p>
         </p:txBody>
       </p:sp>
+      <p:pic>
+        <p:nvPicPr>
+          <p:cNvPr id="6" name="Picture 5" descr="dw-pause.jpg"/>
+          <p:cNvPicPr>
+            <a:picLocks noChangeAspect="1"/>
+          </p:cNvPicPr>
+          <p:nvPr/>
+        </p:nvPicPr>
+        <p:blipFill>
+          <a:blip r:embed="rId2"/>
+          <a:stretch>
+            <a:fillRect/>
+          </a:stretch>
+        </p:blipFill>
+        <p:spPr>
+          <a:xfrm>
+            <a:off x="8366760" y="1874519"/>
+            <a:ext cx="3246120" cy="3246120"/>
+          </a:xfrm>
+          <a:prstGeom prst="rect">
+            <a:avLst/>
+          </a:prstGeom>
+        </p:spPr>
+      </p:pic>
     </p:spTree>
   </p:cSld>
   <p:clrMapOvr>
@@ -5035,8 +5131,8 @@
         </p:nvSpPr>
         <p:spPr>
           <a:xfrm>
-            <a:off x="640080" y="685800"/>
-            <a:ext cx="10972800" cy="1463040"/>
+            <a:off x="640080" y="658368"/>
+            <a:ext cx="7863840" cy="1645920"/>
           </a:xfrm>
           <a:prstGeom prst="rect">
             <a:avLst/>
@@ -5050,7 +5146,7 @@
           <a:lstStyle/>
           <a:p>
             <a:r>
-              <a:rPr sz="3200" b="1">
+              <a:rPr sz="3000" b="1">
                 <a:solidFill>
                   <a:srgbClr val="FFFFFF"/>
                 </a:solidFill>
@@ -5069,8 +5165,8 @@
         </p:nvSpPr>
         <p:spPr>
           <a:xfrm>
-            <a:off x="777240" y="2286000"/>
-            <a:ext cx="10607040" cy="4754880"/>
+            <a:off x="777240" y="2331720"/>
+            <a:ext cx="7498079" cy="4754880"/>
           </a:xfrm>
           <a:prstGeom prst="rect">
             <a:avLst/>
@@ -5089,7 +5185,7 @@
               </a:spcAft>
             </a:pPr>
             <a:r>
-              <a:rPr sz="2400" b="0">
+              <a:rPr sz="2200" b="0">
                 <a:solidFill>
                   <a:srgbClr val="FFFFFF"/>
                 </a:solidFill>
@@ -5105,7 +5201,7 @@
               </a:spcAft>
             </a:pPr>
             <a:r>
-              <a:rPr sz="2400" b="0">
+              <a:rPr sz="2200" b="0">
                 <a:solidFill>
                   <a:srgbClr val="FFFFFF"/>
                 </a:solidFill>
@@ -5116,6 +5212,30 @@
           </a:p>
         </p:txBody>
       </p:sp>
+      <p:pic>
+        <p:nvPicPr>
+          <p:cNvPr id="6" name="Picture 5" descr="dw-hero-transform.jpg"/>
+          <p:cNvPicPr>
+            <a:picLocks noChangeAspect="1"/>
+          </p:cNvPicPr>
+          <p:nvPr/>
+        </p:nvPicPr>
+        <p:blipFill>
+          <a:blip r:embed="rId2"/>
+          <a:stretch>
+            <a:fillRect/>
+          </a:stretch>
+        </p:blipFill>
+        <p:spPr>
+          <a:xfrm>
+            <a:off x="8732520" y="2057400"/>
+            <a:ext cx="2880360" cy="2880360"/>
+          </a:xfrm>
+          <a:prstGeom prst="rect">
+            <a:avLst/>
+          </a:prstGeom>
+        </p:spPr>
+      </p:pic>
     </p:spTree>
   </p:cSld>
   <p:clrMapOvr>
@@ -5219,8 +5339,8 @@
         </p:nvSpPr>
         <p:spPr>
           <a:xfrm>
-            <a:off x="640080" y="685800"/>
-            <a:ext cx="10972800" cy="1463040"/>
+            <a:off x="640080" y="658368"/>
+            <a:ext cx="10972800" cy="1645920"/>
           </a:xfrm>
           <a:prstGeom prst="rect">
             <a:avLst/>
@@ -5234,7 +5354,7 @@
           <a:lstStyle/>
           <a:p>
             <a:r>
-              <a:rPr sz="3200" b="1">
+              <a:rPr sz="3000" b="1">
                 <a:solidFill>
                   <a:srgbClr val="FFFFFF"/>
                 </a:solidFill>
@@ -5500,8 +5620,8 @@
         </p:nvSpPr>
         <p:spPr>
           <a:xfrm>
-            <a:off x="640080" y="685800"/>
-            <a:ext cx="10972800" cy="1463040"/>
+            <a:off x="640080" y="658368"/>
+            <a:ext cx="10972800" cy="1645920"/>
           </a:xfrm>
           <a:prstGeom prst="rect">
             <a:avLst/>
@@ -5515,7 +5635,7 @@
           <a:lstStyle/>
           <a:p>
             <a:r>
-              <a:rPr sz="3200" b="1">
+              <a:rPr sz="3000" b="1">
                 <a:solidFill>
                   <a:srgbClr val="FFFFFF"/>
                 </a:solidFill>
@@ -5733,8 +5853,8 @@
         </p:nvSpPr>
         <p:spPr>
           <a:xfrm>
-            <a:off x="640080" y="685800"/>
-            <a:ext cx="10972800" cy="1463040"/>
+            <a:off x="640080" y="658368"/>
+            <a:ext cx="7863840" cy="1645920"/>
           </a:xfrm>
           <a:prstGeom prst="rect">
             <a:avLst/>
@@ -5748,7 +5868,7 @@
           <a:lstStyle/>
           <a:p>
             <a:r>
-              <a:rPr sz="3200" b="1">
+              <a:rPr sz="3000" b="1">
                 <a:solidFill>
                   <a:srgbClr val="FFFFFF"/>
                 </a:solidFill>
@@ -5767,8 +5887,8 @@
         </p:nvSpPr>
         <p:spPr>
           <a:xfrm>
-            <a:off x="777240" y="2286000"/>
-            <a:ext cx="10607040" cy="4754880"/>
+            <a:off x="777240" y="2331720"/>
+            <a:ext cx="7498079" cy="4754880"/>
           </a:xfrm>
           <a:prstGeom prst="rect">
             <a:avLst/>
@@ -5787,7 +5907,7 @@
               </a:spcAft>
             </a:pPr>
             <a:r>
-              <a:rPr sz="2400" b="0">
+              <a:rPr sz="2200" b="0">
                 <a:solidFill>
                   <a:srgbClr val="FFFFFF"/>
                 </a:solidFill>
@@ -5803,7 +5923,7 @@
               </a:spcAft>
             </a:pPr>
             <a:r>
-              <a:rPr sz="2400" b="0">
+              <a:rPr sz="2200" b="0">
                 <a:solidFill>
                   <a:srgbClr val="FFFFFF"/>
                 </a:solidFill>
@@ -5819,7 +5939,7 @@
               </a:spcAft>
             </a:pPr>
             <a:r>
-              <a:rPr sz="2400" b="0">
+              <a:rPr sz="2200" b="0">
                 <a:solidFill>
                   <a:srgbClr val="FFFFFF"/>
                 </a:solidFill>
@@ -5830,6 +5950,30 @@
           </a:p>
         </p:txBody>
       </p:sp>
+      <p:pic>
+        <p:nvPicPr>
+          <p:cNvPr id="6" name="Picture 5" descr="dw-interview.jpg"/>
+          <p:cNvPicPr>
+            <a:picLocks noChangeAspect="1"/>
+          </p:cNvPicPr>
+          <p:nvPr/>
+        </p:nvPicPr>
+        <p:blipFill>
+          <a:blip r:embed="rId2"/>
+          <a:stretch>
+            <a:fillRect/>
+          </a:stretch>
+        </p:blipFill>
+        <p:spPr>
+          <a:xfrm>
+            <a:off x="8732520" y="2057400"/>
+            <a:ext cx="2880360" cy="2880360"/>
+          </a:xfrm>
+          <a:prstGeom prst="rect">
+            <a:avLst/>
+          </a:prstGeom>
+        </p:spPr>
+      </p:pic>
     </p:spTree>
   </p:cSld>
   <p:clrMapOvr>

</xml_diff>